<commit_message>
Add vestibular/nystagmus screening feature and vendor vestibular-ai pipeline
Copies the trained pupil-tracking pipeline and models from vestibular-ai
(pupil detection through the explainable HTML report) into healthcare-ai/
vestibular-ai/, adds a run_screening.py orchestrator, and wires it up as a
new /vestibular-screening page + /api/vestibular-screening route. The route
shells out to the local Python pipeline and degrades gracefully (501) where
no Python runtime is available, e.g. the deployed Netlify site and the
current Docker image -- documented in docs/deployment.md.

Also includes pre-existing in-progress rash-photo-analysis wiring
(app/api/rash-analysis, journal page changes, lib/models.ts,
lib/prompts/aura.ts, lib/validation.ts, lib/journal-client.ts) that was
already uncommitted in this working tree.

Co-Authored-By: Claude Sonnet 5 <noreply@anthropic.com>
Claude-Session: https://claude.ai/code/session_01QtqQ3KeMjBptX5TyBLzk1z
</commit_message>
<xml_diff>
--- a/artifacts/ClearSignal_RapidFire_3min.pptx
+++ b/artifacts/ClearSignal_RapidFire_3min.pptx
@@ -11791,7 +11791,7 @@
         <p:spPr>
           <a:xfrm>
             <a:off x="640080" y="1783080"/>
-            <a:ext cx="10881360" cy="4206240"/>
+            <a:ext cx="10881360" cy="4500000"/>
           </a:xfrm>
           <a:prstGeom prst="rect">
             <a:avLst/>
@@ -11800,7 +11800,7 @@
         </p:spPr>
         <p:txBody>
           <a:bodyPr wrap="square">
-            <a:spAutoFit/>
+            <a:normAutofit fontScale="88000" lnSpcReduction="10000"/>
           </a:bodyPr>
           <a:lstStyle/>
           <a:p>
@@ -11926,6 +11926,31 @@
                 <a:latin typeface="Calibri"/>
               </a:rPr>
               <a:t>compiles the above into a one-page, clinician-readable document — under a deterministic safety layer that never diagnoses.</a:t>
+            </a:r>
+          </a:p>
+          <a:p>
+            <a:pPr>
+              <a:spcAft>
+                <a:spcPts val="1400"/>
+              </a:spcAft>
+            </a:pPr>
+            <a:r>
+              <a:rPr sz="1700" b="1">
+                <a:solidFill>
+                  <a:srgbClr val="FFFFFF"/>
+                </a:solidFill>
+                <a:latin typeface="Calibri"/>
+              </a:rPr>
+              <a:t>•  Confidence rail  </a:t>
+            </a:r>
+            <a:r>
+              <a:rPr sz="1700">
+                <a:solidFill>
+                  <a:srgbClr val="C9D6E3"/>
+                </a:solidFill>
+                <a:latin typeface="Calibri"/>
+              </a:rPr>
+              <a:t>beside every answer renders the same retrieval-confidence score the eval harness computes — never invented, never buried in prose.</a:t>
             </a:r>
           </a:p>
         </p:txBody>

</xml_diff>